<commit_message>
Replace teacher notes with a class question on each slide
Every slide now carries a discussion question for the class instead of
teacher notes, in both the PPTX notes and the site panel.
</commit_message>
<xml_diff>
--- a/biology/assets/downloads/Многощетинковые_черви_и_пиявки.pptx
+++ b/biology/assets/downloads/Многощетинковые_черви_и_пиявки.pptx
@@ -513,7 +513,7 @@
           <a:lstStyle/>
           <a:p>
             <a:r>
-              <a:t>Приветствие. Сегодня тема «Многощетинковые черви. Пиявки» — это два класса типа Кольчатые черви. Напомните, что дождевой червь — тоже кольчец, с ним будем сравнивать.</a:t>
+              <a:t>Дождевой червь — знакомый нам кольчатый червь. А где ещё в природе живут кольчатые черви?</a:t>
             </a:r>
           </a:p>
         </p:txBody>
@@ -583,7 +583,7 @@
           <a:lstStyle/>
           <a:p>
             <a:r>
-              <a:t>Дайте классу 1–2 минуты: пусть сами найдут отличия по таблице, затем проговорите вместе.</a:t>
+              <a:t>Найдите главное отличие: как по строению отличить полихету от пиявки?</a:t>
             </a:r>
           </a:p>
         </p:txBody>
@@ -653,7 +653,7 @@
           <a:lstStyle/>
           <a:p>
             <a:r>
-              <a:t>Три факта про полихет. Дайте паузу после каждого — пусть удивятся. Спросите, какой факт запомнился.</a:t>
+              <a:t>Какой из трёх фактов про полихет удивил вас больше всего и почему?</a:t>
             </a:r>
           </a:p>
         </p:txBody>
@@ -723,7 +723,7 @@
           <a:lstStyle/>
           <a:p>
             <a:r>
-              <a:t>Три факта про пиявок. Обязательно про Красную книгу и чистоту воды — экологический акцент. На этом слайде завершаем тему.</a:t>
+              <a:t>Почему пиявку называют «живым индикатором» чистой воды?</a:t>
             </a:r>
           </a:p>
         </p:txBody>
@@ -793,7 +793,7 @@
           <a:lstStyle/>
           <a:p>
             <a:r>
-              <a:t>Проговорите план урока. Спросите: кто уже слышал про пиявок? Где их видели?</a:t>
+              <a:t>Кто из вас видел пиявку? Где это было — в пруду, в речке, в озере?</a:t>
             </a:r>
           </a:p>
         </p:txBody>
@@ -863,7 +863,7 @@
           <a:lstStyle/>
           <a:p>
             <a:r>
-              <a:t>Ключевая мысль: полихеты — почти исключительно морские животные. Сравните с дождевым червём, который живёт в почве. Спросите, почему в море нужно уметь плавать и ориентироваться.</a:t>
+              <a:t>Почему многощетинковые черви живут в море, а не в почве, как дождевой червь?</a:t>
             </a:r>
           </a:p>
         </p:txBody>
@@ -933,7 +933,7 @@
           <a:lstStyle/>
           <a:p>
             <a:r>
-              <a:t>Разберите три отдела тела и главное — параподии. Подчеркните двойную функцию: движение («вёсла») и дыхание («жабры»). Покажите на схеме. Вопрос: почему у дождевого червя нет параподий?</a:t>
+              <a:t>Зачем червю на каждом сегменте параподии со щетинками — что они делают?</a:t>
             </a:r>
           </a:p>
         </p:txBody>
@@ -1003,7 +1003,7 @@
           <a:lstStyle/>
           <a:p>
             <a:r>
-              <a:t>Акцент: полихеты раздельнополые, оплодотворение наружное, развитие непрямое — есть личинка, не похожая на взрослого. Это важное отличие от дождевого червя.</a:t>
+              <a:t>Чем развитие с личинкой отличается от прямого развития, как у дождевого червя?</a:t>
             </a:r>
           </a:p>
         </p:txBody>
@@ -1073,7 +1073,7 @@
           <a:lstStyle/>
           <a:p>
             <a:r>
-              <a:t>Переход к пиявкам. Спросите: пиявка — это паразит? Разрушьте стереотип: многие пиявки — хищники.</a:t>
+              <a:t>Пиявка — это всегда паразит, который пьёт кровь, или бывает иначе?</a:t>
             </a:r>
           </a:p>
         </p:txBody>
@@ -1143,7 +1143,7 @@
           <a:lstStyle/>
           <a:p>
             <a:r>
-              <a:t>Разберите две присоски и способ движения «шагами»: цепляется задней, тянется вперёд, крепится передней. Спросите, почему одной присоски, как у осьминога, было бы недостаточно.</a:t>
+              <a:t>Почему одной присоски, как у осьминога, пиявке было бы недостаточно?</a:t>
             </a:r>
           </a:p>
         </p:txBody>
@@ -1213,7 +1213,7 @@
           <a:lstStyle/>
           <a:p>
             <a:r>
-              <a:t>Объясните гирудин простыми словами: вещество, которое не даёт крови сворачиваться. Свяжите с медициной (гирудотерапия). Можно спросить: почему сама пиявка не истекает кровью? У неё своя независимая система свёртывания.</a:t>
+              <a:t>Пиявка вводит гирудин, чтобы кровь не сворачивалась. Почему же тогда она не истекает кровью сама?</a:t>
             </a:r>
           </a:p>
         </p:txBody>
@@ -1283,7 +1283,7 @@
           <a:lstStyle/>
           <a:p>
             <a:r>
-              <a:t>Сравните с полихетами: пиявки — гермафродиты, развитие прямое. Вспомните дождевого червя.</a:t>
+              <a:t>Кто такие гермафродиты? Вспомните, у кого из знакомых животных так же.</a:t>
             </a:r>
           </a:p>
         </p:txBody>

</xml_diff>

<commit_message>
Add a real photo of a polychaete to slide 4
Replace the drawn body diagram with a Wikimedia Commons photograph of
Nereis virens (Alexander Semenov, CC BY 2.0), shown in a frame with a
blurred backdrop built from the same shot, plus a credit line.
</commit_message>
<xml_diff>
--- a/biology/assets/downloads/Многощетинковые_черви_и_пиявки.pptx
+++ b/biology/assets/downloads/Многощетинковые_черви_и_пиявки.pptx
@@ -9259,16 +9259,64 @@
           </a:p>
         </p:txBody>
       </p:sp>
-      <p:sp>
-        <p:nvSpPr>
-          <p:cNvPr id="12" name="TextBox 11"/>
+      <p:pic>
+        <p:nvPicPr>
+          <p:cNvPr id="12" name="Picture 11" descr="pptx_bg_polychaete_nereis.jpg.jpg"/>
+          <p:cNvPicPr>
+            <a:picLocks noChangeAspect="1"/>
+          </p:cNvPicPr>
+          <p:nvPr/>
+        </p:nvPicPr>
+        <p:blipFill>
+          <a:blip r:embed="rId2"/>
+          <a:stretch>
+            <a:fillRect/>
+          </a:stretch>
+        </p:blipFill>
+        <p:spPr>
+          <a:xfrm>
+            <a:off x="6510528" y="1664208"/>
+            <a:ext cx="4992624" cy="4261104"/>
+          </a:xfrm>
+          <a:prstGeom prst="rect">
+            <a:avLst/>
+          </a:prstGeom>
+        </p:spPr>
+      </p:pic>
+      <p:pic>
+        <p:nvPicPr>
+          <p:cNvPr id="13" name="Picture 12" descr="polychaete_nereis.jpg"/>
+          <p:cNvPicPr>
+            <a:picLocks noChangeAspect="1"/>
+          </p:cNvPicPr>
+          <p:nvPr/>
+        </p:nvPicPr>
+        <p:blipFill>
+          <a:blip r:embed="rId3"/>
+          <a:stretch>
+            <a:fillRect/>
+          </a:stretch>
+        </p:blipFill>
+        <p:spPr>
+          <a:xfrm>
+            <a:off x="6620256" y="2171883"/>
+            <a:ext cx="4773168" cy="3245754"/>
+          </a:xfrm>
+          <a:prstGeom prst="rect">
+            <a:avLst/>
+          </a:prstGeom>
+        </p:spPr>
+      </p:pic>
+      <p:sp>
+        <p:nvSpPr>
+          <p:cNvPr id="14" name="TextBox 13"/>
           <p:cNvSpPr txBox="1"/>
           <p:nvPr/>
         </p:nvSpPr>
         <p:spPr>
           <a:xfrm>
-            <a:off x="6675120" y="1783080"/>
-            <a:ext cx="4663440" cy="548640"/>
+            <a:off x="6400800" y="6053328"/>
+            <a:ext cx="5212080" cy="457200"/>
           </a:xfrm>
           <a:prstGeom prst="rect">
             <a:avLst/>
@@ -9290,980 +9338,20 @@
               </a:spcAft>
             </a:pPr>
             <a:r>
-              <a:rPr sz="1800" b="1" i="0">
-                <a:solidFill>
-                  <a:srgbClr val="5FC9A6"/>
-                </a:solidFill>
-                <a:latin typeface="Calibri"/>
-              </a:rPr>
-              <a:t>Схема тела</a:t>
-            </a:r>
-          </a:p>
-        </p:txBody>
-      </p:sp>
-      <p:sp>
-        <p:nvSpPr>
-          <p:cNvPr id="13" name="Rounded Rectangle 12"/>
-          <p:cNvSpPr/>
-          <p:nvPr/>
-        </p:nvSpPr>
-        <p:spPr>
-          <a:xfrm>
-            <a:off x="6675120" y="3154680"/>
-            <a:ext cx="4572000" cy="822960"/>
-          </a:xfrm>
-          <a:prstGeom prst="roundRect">
-            <a:avLst/>
-          </a:prstGeom>
-          <a:solidFill>
-            <a:srgbClr val="179EA0"/>
-          </a:solidFill>
-          <a:ln>
-            <a:noFill/>
-          </a:ln>
-          <a:effectLst/>
-        </p:spPr>
-        <p:style>
-          <a:lnRef idx="1">
-            <a:schemeClr val="accent1"/>
-          </a:lnRef>
-          <a:fillRef idx="3">
-            <a:schemeClr val="accent1"/>
-          </a:fillRef>
-          <a:effectRef idx="2">
-            <a:schemeClr val="accent1"/>
-          </a:effectRef>
-          <a:fontRef idx="minor">
-            <a:schemeClr val="lt1"/>
-          </a:fontRef>
-        </p:style>
-        <p:txBody>
-          <a:bodyPr rtlCol="0" anchor="ctr"/>
-          <a:lstStyle/>
-          <a:p>
-            <a:pPr algn="ctr"/>
-          </a:p>
-        </p:txBody>
-      </p:sp>
-      <p:sp>
-        <p:nvSpPr>
-          <p:cNvPr id="14" name="Oval 13"/>
-          <p:cNvSpPr/>
-          <p:nvPr/>
-        </p:nvSpPr>
-        <p:spPr>
-          <a:xfrm>
-            <a:off x="6629400" y="3108960"/>
-            <a:ext cx="685800" cy="914400"/>
-          </a:xfrm>
-          <a:prstGeom prst="ellipse">
-            <a:avLst/>
-          </a:prstGeom>
-          <a:solidFill>
-            <a:srgbClr val="5FC9A6"/>
-          </a:solidFill>
-          <a:ln>
-            <a:noFill/>
-          </a:ln>
-          <a:effectLst/>
-        </p:spPr>
-        <p:style>
-          <a:lnRef idx="1">
-            <a:schemeClr val="accent1"/>
-          </a:lnRef>
-          <a:fillRef idx="3">
-            <a:schemeClr val="accent1"/>
-          </a:fillRef>
-          <a:effectRef idx="2">
-            <a:schemeClr val="accent1"/>
-          </a:effectRef>
-          <a:fontRef idx="minor">
-            <a:schemeClr val="lt1"/>
-          </a:fontRef>
-        </p:style>
-        <p:txBody>
-          <a:bodyPr rtlCol="0" anchor="ctr"/>
-          <a:lstStyle/>
-          <a:p>
-            <a:pPr algn="ctr"/>
-          </a:p>
-        </p:txBody>
-      </p:sp>
-      <p:sp>
-        <p:nvSpPr>
-          <p:cNvPr id="15" name="Rectangle 14"/>
-          <p:cNvSpPr/>
-          <p:nvPr/>
-        </p:nvSpPr>
-        <p:spPr>
-          <a:xfrm>
-            <a:off x="7452360" y="3090672"/>
-            <a:ext cx="457200" cy="950976"/>
-          </a:xfrm>
-          <a:prstGeom prst="rect">
-            <a:avLst/>
-          </a:prstGeom>
-          <a:solidFill>
-            <a:srgbClr val="0E4A74"/>
-          </a:solidFill>
-          <a:ln>
-            <a:noFill/>
-          </a:ln>
-          <a:effectLst/>
-        </p:spPr>
-        <p:style>
-          <a:lnRef idx="1">
-            <a:schemeClr val="accent1"/>
-          </a:lnRef>
-          <a:fillRef idx="3">
-            <a:schemeClr val="accent1"/>
-          </a:fillRef>
-          <a:effectRef idx="2">
-            <a:schemeClr val="accent1"/>
-          </a:effectRef>
-          <a:fontRef idx="minor">
-            <a:schemeClr val="lt1"/>
-          </a:fontRef>
-        </p:style>
-        <p:txBody>
-          <a:bodyPr rtlCol="0" anchor="ctr"/>
-          <a:lstStyle/>
-          <a:p>
-            <a:pPr algn="ctr"/>
-          </a:p>
-        </p:txBody>
-      </p:sp>
-      <p:sp>
-        <p:nvSpPr>
-          <p:cNvPr id="16" name="Oval 15"/>
-          <p:cNvSpPr/>
-          <p:nvPr/>
-        </p:nvSpPr>
-        <p:spPr>
-          <a:xfrm>
-            <a:off x="7525512" y="2788920"/>
-            <a:ext cx="310896" cy="292608"/>
-          </a:xfrm>
-          <a:prstGeom prst="ellipse">
-            <a:avLst/>
-          </a:prstGeom>
-          <a:solidFill>
-            <a:srgbClr val="E8A83A"/>
-          </a:solidFill>
-          <a:ln>
-            <a:noFill/>
-          </a:ln>
-          <a:effectLst/>
-        </p:spPr>
-        <p:style>
-          <a:lnRef idx="1">
-            <a:schemeClr val="accent1"/>
-          </a:lnRef>
-          <a:fillRef idx="3">
-            <a:schemeClr val="accent1"/>
-          </a:fillRef>
-          <a:effectRef idx="2">
-            <a:schemeClr val="accent1"/>
-          </a:effectRef>
-          <a:fontRef idx="minor">
-            <a:schemeClr val="lt1"/>
-          </a:fontRef>
-        </p:style>
-        <p:txBody>
-          <a:bodyPr rtlCol="0" anchor="ctr"/>
-          <a:lstStyle/>
-          <a:p>
-            <a:pPr algn="ctr"/>
-          </a:p>
-        </p:txBody>
-      </p:sp>
-      <p:sp>
-        <p:nvSpPr>
-          <p:cNvPr id="17" name="Oval 16"/>
-          <p:cNvSpPr/>
-          <p:nvPr/>
-        </p:nvSpPr>
-        <p:spPr>
-          <a:xfrm>
-            <a:off x="7525512" y="4041648"/>
-            <a:ext cx="310896" cy="292608"/>
-          </a:xfrm>
-          <a:prstGeom prst="ellipse">
-            <a:avLst/>
-          </a:prstGeom>
-          <a:solidFill>
-            <a:srgbClr val="E8A83A"/>
-          </a:solidFill>
-          <a:ln>
-            <a:noFill/>
-          </a:ln>
-          <a:effectLst/>
-        </p:spPr>
-        <p:style>
-          <a:lnRef idx="1">
-            <a:schemeClr val="accent1"/>
-          </a:lnRef>
-          <a:fillRef idx="3">
-            <a:schemeClr val="accent1"/>
-          </a:fillRef>
-          <a:effectRef idx="2">
-            <a:schemeClr val="accent1"/>
-          </a:effectRef>
-          <a:fontRef idx="minor">
-            <a:schemeClr val="lt1"/>
-          </a:fontRef>
-        </p:style>
-        <p:txBody>
-          <a:bodyPr rtlCol="0" anchor="ctr"/>
-          <a:lstStyle/>
-          <a:p>
-            <a:pPr algn="ctr"/>
-          </a:p>
-        </p:txBody>
-      </p:sp>
-      <p:sp>
-        <p:nvSpPr>
-          <p:cNvPr id="18" name="Rectangle 17"/>
-          <p:cNvSpPr/>
-          <p:nvPr/>
-        </p:nvSpPr>
-        <p:spPr>
-          <a:xfrm>
-            <a:off x="8092440" y="3090672"/>
-            <a:ext cx="457200" cy="950976"/>
-          </a:xfrm>
-          <a:prstGeom prst="rect">
-            <a:avLst/>
-          </a:prstGeom>
-          <a:solidFill>
-            <a:srgbClr val="0E4A74"/>
-          </a:solidFill>
-          <a:ln>
-            <a:noFill/>
-          </a:ln>
-          <a:effectLst/>
-        </p:spPr>
-        <p:style>
-          <a:lnRef idx="1">
-            <a:schemeClr val="accent1"/>
-          </a:lnRef>
-          <a:fillRef idx="3">
-            <a:schemeClr val="accent1"/>
-          </a:fillRef>
-          <a:effectRef idx="2">
-            <a:schemeClr val="accent1"/>
-          </a:effectRef>
-          <a:fontRef idx="minor">
-            <a:schemeClr val="lt1"/>
-          </a:fontRef>
-        </p:style>
-        <p:txBody>
-          <a:bodyPr rtlCol="0" anchor="ctr"/>
-          <a:lstStyle/>
-          <a:p>
-            <a:pPr algn="ctr"/>
-          </a:p>
-        </p:txBody>
-      </p:sp>
-      <p:sp>
-        <p:nvSpPr>
-          <p:cNvPr id="19" name="Oval 18"/>
-          <p:cNvSpPr/>
-          <p:nvPr/>
-        </p:nvSpPr>
-        <p:spPr>
-          <a:xfrm>
-            <a:off x="8165592" y="2788920"/>
-            <a:ext cx="310896" cy="292608"/>
-          </a:xfrm>
-          <a:prstGeom prst="ellipse">
-            <a:avLst/>
-          </a:prstGeom>
-          <a:solidFill>
-            <a:srgbClr val="E8A83A"/>
-          </a:solidFill>
-          <a:ln>
-            <a:noFill/>
-          </a:ln>
-          <a:effectLst/>
-        </p:spPr>
-        <p:style>
-          <a:lnRef idx="1">
-            <a:schemeClr val="accent1"/>
-          </a:lnRef>
-          <a:fillRef idx="3">
-            <a:schemeClr val="accent1"/>
-          </a:fillRef>
-          <a:effectRef idx="2">
-            <a:schemeClr val="accent1"/>
-          </a:effectRef>
-          <a:fontRef idx="minor">
-            <a:schemeClr val="lt1"/>
-          </a:fontRef>
-        </p:style>
-        <p:txBody>
-          <a:bodyPr rtlCol="0" anchor="ctr"/>
-          <a:lstStyle/>
-          <a:p>
-            <a:pPr algn="ctr"/>
-          </a:p>
-        </p:txBody>
-      </p:sp>
-      <p:sp>
-        <p:nvSpPr>
-          <p:cNvPr id="20" name="Oval 19"/>
-          <p:cNvSpPr/>
-          <p:nvPr/>
-        </p:nvSpPr>
-        <p:spPr>
-          <a:xfrm>
-            <a:off x="8165592" y="4041648"/>
-            <a:ext cx="310896" cy="292608"/>
-          </a:xfrm>
-          <a:prstGeom prst="ellipse">
-            <a:avLst/>
-          </a:prstGeom>
-          <a:solidFill>
-            <a:srgbClr val="E8A83A"/>
-          </a:solidFill>
-          <a:ln>
-            <a:noFill/>
-          </a:ln>
-          <a:effectLst/>
-        </p:spPr>
-        <p:style>
-          <a:lnRef idx="1">
-            <a:schemeClr val="accent1"/>
-          </a:lnRef>
-          <a:fillRef idx="3">
-            <a:schemeClr val="accent1"/>
-          </a:fillRef>
-          <a:effectRef idx="2">
-            <a:schemeClr val="accent1"/>
-          </a:effectRef>
-          <a:fontRef idx="minor">
-            <a:schemeClr val="lt1"/>
-          </a:fontRef>
-        </p:style>
-        <p:txBody>
-          <a:bodyPr rtlCol="0" anchor="ctr"/>
-          <a:lstStyle/>
-          <a:p>
-            <a:pPr algn="ctr"/>
-          </a:p>
-        </p:txBody>
-      </p:sp>
-      <p:sp>
-        <p:nvSpPr>
-          <p:cNvPr id="21" name="Rectangle 20"/>
-          <p:cNvSpPr/>
-          <p:nvPr/>
-        </p:nvSpPr>
-        <p:spPr>
-          <a:xfrm>
-            <a:off x="8732520" y="3090672"/>
-            <a:ext cx="457200" cy="950976"/>
-          </a:xfrm>
-          <a:prstGeom prst="rect">
-            <a:avLst/>
-          </a:prstGeom>
-          <a:solidFill>
-            <a:srgbClr val="0E4A74"/>
-          </a:solidFill>
-          <a:ln>
-            <a:noFill/>
-          </a:ln>
-          <a:effectLst/>
-        </p:spPr>
-        <p:style>
-          <a:lnRef idx="1">
-            <a:schemeClr val="accent1"/>
-          </a:lnRef>
-          <a:fillRef idx="3">
-            <a:schemeClr val="accent1"/>
-          </a:fillRef>
-          <a:effectRef idx="2">
-            <a:schemeClr val="accent1"/>
-          </a:effectRef>
-          <a:fontRef idx="minor">
-            <a:schemeClr val="lt1"/>
-          </a:fontRef>
-        </p:style>
-        <p:txBody>
-          <a:bodyPr rtlCol="0" anchor="ctr"/>
-          <a:lstStyle/>
-          <a:p>
-            <a:pPr algn="ctr"/>
-          </a:p>
-        </p:txBody>
-      </p:sp>
-      <p:sp>
-        <p:nvSpPr>
-          <p:cNvPr id="22" name="Oval 21"/>
-          <p:cNvSpPr/>
-          <p:nvPr/>
-        </p:nvSpPr>
-        <p:spPr>
-          <a:xfrm>
-            <a:off x="8805672" y="2788920"/>
-            <a:ext cx="310896" cy="292608"/>
-          </a:xfrm>
-          <a:prstGeom prst="ellipse">
-            <a:avLst/>
-          </a:prstGeom>
-          <a:solidFill>
-            <a:srgbClr val="E8A83A"/>
-          </a:solidFill>
-          <a:ln>
-            <a:noFill/>
-          </a:ln>
-          <a:effectLst/>
-        </p:spPr>
-        <p:style>
-          <a:lnRef idx="1">
-            <a:schemeClr val="accent1"/>
-          </a:lnRef>
-          <a:fillRef idx="3">
-            <a:schemeClr val="accent1"/>
-          </a:fillRef>
-          <a:effectRef idx="2">
-            <a:schemeClr val="accent1"/>
-          </a:effectRef>
-          <a:fontRef idx="minor">
-            <a:schemeClr val="lt1"/>
-          </a:fontRef>
-        </p:style>
-        <p:txBody>
-          <a:bodyPr rtlCol="0" anchor="ctr"/>
-          <a:lstStyle/>
-          <a:p>
-            <a:pPr algn="ctr"/>
-          </a:p>
-        </p:txBody>
-      </p:sp>
-      <p:sp>
-        <p:nvSpPr>
-          <p:cNvPr id="23" name="Oval 22"/>
-          <p:cNvSpPr/>
-          <p:nvPr/>
-        </p:nvSpPr>
-        <p:spPr>
-          <a:xfrm>
-            <a:off x="8805672" y="4041648"/>
-            <a:ext cx="310896" cy="292608"/>
-          </a:xfrm>
-          <a:prstGeom prst="ellipse">
-            <a:avLst/>
-          </a:prstGeom>
-          <a:solidFill>
-            <a:srgbClr val="E8A83A"/>
-          </a:solidFill>
-          <a:ln>
-            <a:noFill/>
-          </a:ln>
-          <a:effectLst/>
-        </p:spPr>
-        <p:style>
-          <a:lnRef idx="1">
-            <a:schemeClr val="accent1"/>
-          </a:lnRef>
-          <a:fillRef idx="3">
-            <a:schemeClr val="accent1"/>
-          </a:fillRef>
-          <a:effectRef idx="2">
-            <a:schemeClr val="accent1"/>
-          </a:effectRef>
-          <a:fontRef idx="minor">
-            <a:schemeClr val="lt1"/>
-          </a:fontRef>
-        </p:style>
-        <p:txBody>
-          <a:bodyPr rtlCol="0" anchor="ctr"/>
-          <a:lstStyle/>
-          <a:p>
-            <a:pPr algn="ctr"/>
-          </a:p>
-        </p:txBody>
-      </p:sp>
-      <p:sp>
-        <p:nvSpPr>
-          <p:cNvPr id="24" name="Rectangle 23"/>
-          <p:cNvSpPr/>
-          <p:nvPr/>
-        </p:nvSpPr>
-        <p:spPr>
-          <a:xfrm>
-            <a:off x="9372600" y="3090672"/>
-            <a:ext cx="457200" cy="950976"/>
-          </a:xfrm>
-          <a:prstGeom prst="rect">
-            <a:avLst/>
-          </a:prstGeom>
-          <a:solidFill>
-            <a:srgbClr val="0E4A74"/>
-          </a:solidFill>
-          <a:ln>
-            <a:noFill/>
-          </a:ln>
-          <a:effectLst/>
-        </p:spPr>
-        <p:style>
-          <a:lnRef idx="1">
-            <a:schemeClr val="accent1"/>
-          </a:lnRef>
-          <a:fillRef idx="3">
-            <a:schemeClr val="accent1"/>
-          </a:fillRef>
-          <a:effectRef idx="2">
-            <a:schemeClr val="accent1"/>
-          </a:effectRef>
-          <a:fontRef idx="minor">
-            <a:schemeClr val="lt1"/>
-          </a:fontRef>
-        </p:style>
-        <p:txBody>
-          <a:bodyPr rtlCol="0" anchor="ctr"/>
-          <a:lstStyle/>
-          <a:p>
-            <a:pPr algn="ctr"/>
-          </a:p>
-        </p:txBody>
-      </p:sp>
-      <p:sp>
-        <p:nvSpPr>
-          <p:cNvPr id="25" name="Oval 24"/>
-          <p:cNvSpPr/>
-          <p:nvPr/>
-        </p:nvSpPr>
-        <p:spPr>
-          <a:xfrm>
-            <a:off x="9445752" y="2788920"/>
-            <a:ext cx="310896" cy="292608"/>
-          </a:xfrm>
-          <a:prstGeom prst="ellipse">
-            <a:avLst/>
-          </a:prstGeom>
-          <a:solidFill>
-            <a:srgbClr val="E8A83A"/>
-          </a:solidFill>
-          <a:ln>
-            <a:noFill/>
-          </a:ln>
-          <a:effectLst/>
-        </p:spPr>
-        <p:style>
-          <a:lnRef idx="1">
-            <a:schemeClr val="accent1"/>
-          </a:lnRef>
-          <a:fillRef idx="3">
-            <a:schemeClr val="accent1"/>
-          </a:fillRef>
-          <a:effectRef idx="2">
-            <a:schemeClr val="accent1"/>
-          </a:effectRef>
-          <a:fontRef idx="minor">
-            <a:schemeClr val="lt1"/>
-          </a:fontRef>
-        </p:style>
-        <p:txBody>
-          <a:bodyPr rtlCol="0" anchor="ctr"/>
-          <a:lstStyle/>
-          <a:p>
-            <a:pPr algn="ctr"/>
-          </a:p>
-        </p:txBody>
-      </p:sp>
-      <p:sp>
-        <p:nvSpPr>
-          <p:cNvPr id="26" name="Oval 25"/>
-          <p:cNvSpPr/>
-          <p:nvPr/>
-        </p:nvSpPr>
-        <p:spPr>
-          <a:xfrm>
-            <a:off x="9445752" y="4041648"/>
-            <a:ext cx="310896" cy="292608"/>
-          </a:xfrm>
-          <a:prstGeom prst="ellipse">
-            <a:avLst/>
-          </a:prstGeom>
-          <a:solidFill>
-            <a:srgbClr val="E8A83A"/>
-          </a:solidFill>
-          <a:ln>
-            <a:noFill/>
-          </a:ln>
-          <a:effectLst/>
-        </p:spPr>
-        <p:style>
-          <a:lnRef idx="1">
-            <a:schemeClr val="accent1"/>
-          </a:lnRef>
-          <a:fillRef idx="3">
-            <a:schemeClr val="accent1"/>
-          </a:fillRef>
-          <a:effectRef idx="2">
-            <a:schemeClr val="accent1"/>
-          </a:effectRef>
-          <a:fontRef idx="minor">
-            <a:schemeClr val="lt1"/>
-          </a:fontRef>
-        </p:style>
-        <p:txBody>
-          <a:bodyPr rtlCol="0" anchor="ctr"/>
-          <a:lstStyle/>
-          <a:p>
-            <a:pPr algn="ctr"/>
-          </a:p>
-        </p:txBody>
-      </p:sp>
-      <p:sp>
-        <p:nvSpPr>
-          <p:cNvPr id="27" name="Rectangle 26"/>
-          <p:cNvSpPr/>
-          <p:nvPr/>
-        </p:nvSpPr>
-        <p:spPr>
-          <a:xfrm>
-            <a:off x="10012680" y="3090672"/>
-            <a:ext cx="457200" cy="950976"/>
-          </a:xfrm>
-          <a:prstGeom prst="rect">
-            <a:avLst/>
-          </a:prstGeom>
-          <a:solidFill>
-            <a:srgbClr val="0E4A74"/>
-          </a:solidFill>
-          <a:ln>
-            <a:noFill/>
-          </a:ln>
-          <a:effectLst/>
-        </p:spPr>
-        <p:style>
-          <a:lnRef idx="1">
-            <a:schemeClr val="accent1"/>
-          </a:lnRef>
-          <a:fillRef idx="3">
-            <a:schemeClr val="accent1"/>
-          </a:fillRef>
-          <a:effectRef idx="2">
-            <a:schemeClr val="accent1"/>
-          </a:effectRef>
-          <a:fontRef idx="minor">
-            <a:schemeClr val="lt1"/>
-          </a:fontRef>
-        </p:style>
-        <p:txBody>
-          <a:bodyPr rtlCol="0" anchor="ctr"/>
-          <a:lstStyle/>
-          <a:p>
-            <a:pPr algn="ctr"/>
-          </a:p>
-        </p:txBody>
-      </p:sp>
-      <p:sp>
-        <p:nvSpPr>
-          <p:cNvPr id="28" name="Oval 27"/>
-          <p:cNvSpPr/>
-          <p:nvPr/>
-        </p:nvSpPr>
-        <p:spPr>
-          <a:xfrm>
-            <a:off x="10085832" y="2788920"/>
-            <a:ext cx="310896" cy="292608"/>
-          </a:xfrm>
-          <a:prstGeom prst="ellipse">
-            <a:avLst/>
-          </a:prstGeom>
-          <a:solidFill>
-            <a:srgbClr val="E8A83A"/>
-          </a:solidFill>
-          <a:ln>
-            <a:noFill/>
-          </a:ln>
-          <a:effectLst/>
-        </p:spPr>
-        <p:style>
-          <a:lnRef idx="1">
-            <a:schemeClr val="accent1"/>
-          </a:lnRef>
-          <a:fillRef idx="3">
-            <a:schemeClr val="accent1"/>
-          </a:fillRef>
-          <a:effectRef idx="2">
-            <a:schemeClr val="accent1"/>
-          </a:effectRef>
-          <a:fontRef idx="minor">
-            <a:schemeClr val="lt1"/>
-          </a:fontRef>
-        </p:style>
-        <p:txBody>
-          <a:bodyPr rtlCol="0" anchor="ctr"/>
-          <a:lstStyle/>
-          <a:p>
-            <a:pPr algn="ctr"/>
-          </a:p>
-        </p:txBody>
-      </p:sp>
-      <p:sp>
-        <p:nvSpPr>
-          <p:cNvPr id="29" name="Oval 28"/>
-          <p:cNvSpPr/>
-          <p:nvPr/>
-        </p:nvSpPr>
-        <p:spPr>
-          <a:xfrm>
-            <a:off x="10085832" y="4041648"/>
-            <a:ext cx="310896" cy="292608"/>
-          </a:xfrm>
-          <a:prstGeom prst="ellipse">
-            <a:avLst/>
-          </a:prstGeom>
-          <a:solidFill>
-            <a:srgbClr val="E8A83A"/>
-          </a:solidFill>
-          <a:ln>
-            <a:noFill/>
-          </a:ln>
-          <a:effectLst/>
-        </p:spPr>
-        <p:style>
-          <a:lnRef idx="1">
-            <a:schemeClr val="accent1"/>
-          </a:lnRef>
-          <a:fillRef idx="3">
-            <a:schemeClr val="accent1"/>
-          </a:fillRef>
-          <a:effectRef idx="2">
-            <a:schemeClr val="accent1"/>
-          </a:effectRef>
-          <a:fontRef idx="minor">
-            <a:schemeClr val="lt1"/>
-          </a:fontRef>
-        </p:style>
-        <p:txBody>
-          <a:bodyPr rtlCol="0" anchor="ctr"/>
-          <a:lstStyle/>
-          <a:p>
-            <a:pPr algn="ctr"/>
-          </a:p>
-        </p:txBody>
-      </p:sp>
-      <p:sp>
-        <p:nvSpPr>
-          <p:cNvPr id="30" name="Rectangle 29"/>
-          <p:cNvSpPr/>
-          <p:nvPr/>
-        </p:nvSpPr>
-        <p:spPr>
-          <a:xfrm>
-            <a:off x="10652760" y="3090672"/>
-            <a:ext cx="457200" cy="950976"/>
-          </a:xfrm>
-          <a:prstGeom prst="rect">
-            <a:avLst/>
-          </a:prstGeom>
-          <a:solidFill>
-            <a:srgbClr val="0E4A74"/>
-          </a:solidFill>
-          <a:ln>
-            <a:noFill/>
-          </a:ln>
-          <a:effectLst/>
-        </p:spPr>
-        <p:style>
-          <a:lnRef idx="1">
-            <a:schemeClr val="accent1"/>
-          </a:lnRef>
-          <a:fillRef idx="3">
-            <a:schemeClr val="accent1"/>
-          </a:fillRef>
-          <a:effectRef idx="2">
-            <a:schemeClr val="accent1"/>
-          </a:effectRef>
-          <a:fontRef idx="minor">
-            <a:schemeClr val="lt1"/>
-          </a:fontRef>
-        </p:style>
-        <p:txBody>
-          <a:bodyPr rtlCol="0" anchor="ctr"/>
-          <a:lstStyle/>
-          <a:p>
-            <a:pPr algn="ctr"/>
-          </a:p>
-        </p:txBody>
-      </p:sp>
-      <p:sp>
-        <p:nvSpPr>
-          <p:cNvPr id="31" name="Oval 30"/>
-          <p:cNvSpPr/>
-          <p:nvPr/>
-        </p:nvSpPr>
-        <p:spPr>
-          <a:xfrm>
-            <a:off x="10725912" y="2788920"/>
-            <a:ext cx="310896" cy="292608"/>
-          </a:xfrm>
-          <a:prstGeom prst="ellipse">
-            <a:avLst/>
-          </a:prstGeom>
-          <a:solidFill>
-            <a:srgbClr val="E8A83A"/>
-          </a:solidFill>
-          <a:ln>
-            <a:noFill/>
-          </a:ln>
-          <a:effectLst/>
-        </p:spPr>
-        <p:style>
-          <a:lnRef idx="1">
-            <a:schemeClr val="accent1"/>
-          </a:lnRef>
-          <a:fillRef idx="3">
-            <a:schemeClr val="accent1"/>
-          </a:fillRef>
-          <a:effectRef idx="2">
-            <a:schemeClr val="accent1"/>
-          </a:effectRef>
-          <a:fontRef idx="minor">
-            <a:schemeClr val="lt1"/>
-          </a:fontRef>
-        </p:style>
-        <p:txBody>
-          <a:bodyPr rtlCol="0" anchor="ctr"/>
-          <a:lstStyle/>
-          <a:p>
-            <a:pPr algn="ctr"/>
-          </a:p>
-        </p:txBody>
-      </p:sp>
-      <p:sp>
-        <p:nvSpPr>
-          <p:cNvPr id="32" name="Oval 31"/>
-          <p:cNvSpPr/>
-          <p:nvPr/>
-        </p:nvSpPr>
-        <p:spPr>
-          <a:xfrm>
-            <a:off x="10725912" y="4041648"/>
-            <a:ext cx="310896" cy="292608"/>
-          </a:xfrm>
-          <a:prstGeom prst="ellipse">
-            <a:avLst/>
-          </a:prstGeom>
-          <a:solidFill>
-            <a:srgbClr val="E8A83A"/>
-          </a:solidFill>
-          <a:ln>
-            <a:noFill/>
-          </a:ln>
-          <a:effectLst/>
-        </p:spPr>
-        <p:style>
-          <a:lnRef idx="1">
-            <a:schemeClr val="accent1"/>
-          </a:lnRef>
-          <a:fillRef idx="3">
-            <a:schemeClr val="accent1"/>
-          </a:fillRef>
-          <a:effectRef idx="2">
-            <a:schemeClr val="accent1"/>
-          </a:effectRef>
-          <a:fontRef idx="minor">
-            <a:schemeClr val="lt1"/>
-          </a:fontRef>
-        </p:style>
-        <p:txBody>
-          <a:bodyPr rtlCol="0" anchor="ctr"/>
-          <a:lstStyle/>
-          <a:p>
-            <a:pPr algn="ctr"/>
-          </a:p>
-        </p:txBody>
-      </p:sp>
-      <p:sp>
-        <p:nvSpPr>
-          <p:cNvPr id="33" name="TextBox 32"/>
-          <p:cNvSpPr txBox="1"/>
-          <p:nvPr/>
-        </p:nvSpPr>
-        <p:spPr>
-          <a:xfrm>
-            <a:off x="6675120" y="4572000"/>
-            <a:ext cx="4663440" cy="1280160"/>
-          </a:xfrm>
-          <a:prstGeom prst="rect">
-            <a:avLst/>
-          </a:prstGeom>
-          <a:noFill/>
-        </p:spPr>
-        <p:txBody>
-          <a:bodyPr wrap="square" anchor="t">
-            <a:spAutoFit/>
-          </a:bodyPr>
-          <a:lstStyle/>
-          <a:p>
-            <a:pPr algn="l">
-              <a:spcBef>
-                <a:spcPts val="0"/>
-              </a:spcBef>
-              <a:spcAft>
-                <a:spcPts val="400"/>
-              </a:spcAft>
-            </a:pPr>
-            <a:r>
-              <a:rPr sz="1200" b="0" i="0">
-                <a:solidFill>
-                  <a:srgbClr val="CFE3EE"/>
-                </a:solidFill>
-                <a:latin typeface="Calibri"/>
-              </a:rPr>
-              <a:t>Головная лопасть — глаза, щупальца</a:t>
-            </a:r>
-          </a:p>
-          <a:p>
-            <a:pPr algn="l">
-              <a:spcBef>
-                <a:spcPts val="0"/>
-              </a:spcBef>
-              <a:spcAft>
-                <a:spcPts val="400"/>
-              </a:spcAft>
-            </a:pPr>
-            <a:r>
-              <a:rPr sz="1200" b="1" i="0">
-                <a:solidFill>
-                  <a:srgbClr val="E8A83A"/>
-                </a:solidFill>
-                <a:latin typeface="Calibri"/>
-              </a:rPr>
-              <a:t>Жёлтые выросты — параподии со щетинками</a:t>
-            </a:r>
-          </a:p>
-          <a:p>
-            <a:pPr algn="l">
-              <a:spcBef>
-                <a:spcPts val="0"/>
-              </a:spcBef>
-              <a:spcAft>
-                <a:spcPts val="0"/>
-              </a:spcAft>
-            </a:pPr>
-            <a:r>
-              <a:rPr sz="1200" b="0" i="0">
-                <a:solidFill>
-                  <a:srgbClr val="CFE3EE"/>
-                </a:solidFill>
-                <a:latin typeface="Calibri"/>
-              </a:rPr>
-              <a:t>Сегментированное туловище</a:t>
-            </a:r>
-          </a:p>
-        </p:txBody>
-      </p:sp>
-      <p:sp>
-        <p:nvSpPr>
-          <p:cNvPr id="34" name="TextBox 33"/>
+              <a:rPr sz="900" b="0" i="1">
+                <a:solidFill>
+                  <a:srgbClr val="5A6B7B"/>
+                </a:solidFill>
+                <a:latin typeface="Calibri"/>
+              </a:rPr>
+              <a:t>Фото: Nereis virens (Alitta virens) — многощетинковый червь. Alexander Semenov, CC BY 2.0</a:t>
+            </a:r>
+          </a:p>
+        </p:txBody>
+      </p:sp>
+      <p:sp>
+        <p:nvSpPr>
+          <p:cNvPr id="15" name="TextBox 14"/>
           <p:cNvSpPr txBox="1"/>
           <p:nvPr/>
         </p:nvSpPr>

</xml_diff>

<commit_message>
Replace slide photos with labeled anatomy schemes
Slide 4 (polychaete) and slide 7 (leech) now use self-drawn diagrams
with Russian labels instead of photos: labels are legible and there is
no third-party licensing to carry. Rebuilt the PPTX, PDF, slide images
and thumbnails.

Co-authored-by: openhands <openhands@all-hands.dev>
</commit_message>
<xml_diff>
--- a/biology/assets/downloads/Многощетинковые_черви_и_пиявки.pptx
+++ b/biology/assets/downloads/Многощетинковые_черви_и_пиявки.pptx
@@ -9230,10 +9230,12 @@
             <a:avLst/>
           </a:prstGeom>
           <a:solidFill>
-            <a:srgbClr val="0B2E4F"/>
+            <a:srgbClr val="FFFFFF"/>
           </a:solidFill>
-          <a:ln>
-            <a:noFill/>
+          <a:ln w="15875">
+            <a:solidFill>
+              <a:srgbClr val="179EA0"/>
+            </a:solidFill>
           </a:ln>
           <a:effectLst/>
         </p:spPr>
@@ -9261,7 +9263,7 @@
       </p:sp>
       <p:pic>
         <p:nvPicPr>
-          <p:cNvPr id="12" name="Picture 11" descr="pptx_bg_polychaete_nereis.jpg.jpg"/>
+          <p:cNvPr id="12" name="Picture 11" descr="polychaete_scheme_ru.png"/>
           <p:cNvPicPr>
             <a:picLocks noChangeAspect="1"/>
           </p:cNvPicPr>
@@ -9275,41 +9277,17 @@
         </p:blipFill>
         <p:spPr>
           <a:xfrm>
-            <a:off x="6510528" y="1664208"/>
-            <a:ext cx="4992624" cy="4261104"/>
+            <a:off x="6547104" y="2152823"/>
+            <a:ext cx="4919472" cy="3283874"/>
           </a:xfrm>
           <a:prstGeom prst="rect">
             <a:avLst/>
           </a:prstGeom>
         </p:spPr>
       </p:pic>
-      <p:pic>
-        <p:nvPicPr>
-          <p:cNvPr id="13" name="Picture 12" descr="polychaete_nereis.jpg"/>
-          <p:cNvPicPr>
-            <a:picLocks noChangeAspect="1"/>
-          </p:cNvPicPr>
-          <p:nvPr/>
-        </p:nvPicPr>
-        <p:blipFill>
-          <a:blip r:embed="rId3"/>
-          <a:stretch>
-            <a:fillRect/>
-          </a:stretch>
-        </p:blipFill>
-        <p:spPr>
-          <a:xfrm>
-            <a:off x="6620256" y="2171883"/>
-            <a:ext cx="4773168" cy="3245754"/>
-          </a:xfrm>
-          <a:prstGeom prst="rect">
-            <a:avLst/>
-          </a:prstGeom>
-        </p:spPr>
-      </p:pic>
-      <p:sp>
-        <p:nvSpPr>
-          <p:cNvPr id="14" name="TextBox 13"/>
+      <p:sp>
+        <p:nvSpPr>
+          <p:cNvPr id="13" name="TextBox 12"/>
           <p:cNvSpPr txBox="1"/>
           <p:nvPr/>
         </p:nvSpPr>
@@ -9344,14 +9322,14 @@
                 </a:solidFill>
                 <a:latin typeface="Calibri"/>
               </a:rPr>
-              <a:t>Фото: Nereis virens (Alitta virens) — многощетинковый червь. Alexander Semenov, CC BY 2.0</a:t>
-            </a:r>
-          </a:p>
-        </p:txBody>
-      </p:sp>
-      <p:sp>
-        <p:nvSpPr>
-          <p:cNvPr id="15" name="TextBox 14"/>
+              <a:t>Схема: головная и анальная лопасти, сегменты, параподии со щетинками, спинной и брюшной усики.</a:t>
+            </a:r>
+          </a:p>
+        </p:txBody>
+      </p:sp>
+      <p:sp>
+        <p:nvSpPr>
+          <p:cNvPr id="14" name="TextBox 13"/>
           <p:cNvSpPr txBox="1"/>
           <p:nvPr/>
         </p:nvSpPr>
@@ -11669,10 +11647,12 @@
             <a:avLst/>
           </a:prstGeom>
           <a:solidFill>
-            <a:srgbClr val="4A1222"/>
+            <a:srgbClr val="FFFFFF"/>
           </a:solidFill>
-          <a:ln>
-            <a:noFill/>
+          <a:ln w="15875">
+            <a:solidFill>
+              <a:srgbClr val="C03A5B"/>
+            </a:solidFill>
           </a:ln>
           <a:effectLst/>
         </p:spPr>
@@ -11698,16 +11678,40 @@
           </a:p>
         </p:txBody>
       </p:sp>
-      <p:sp>
-        <p:nvSpPr>
-          <p:cNvPr id="12" name="TextBox 11"/>
+      <p:pic>
+        <p:nvPicPr>
+          <p:cNvPr id="12" name="Picture 11" descr="leech_scheme_ru.png"/>
+          <p:cNvPicPr>
+            <a:picLocks noChangeAspect="1"/>
+          </p:cNvPicPr>
+          <p:nvPr/>
+        </p:nvPicPr>
+        <p:blipFill>
+          <a:blip r:embed="rId2"/>
+          <a:stretch>
+            <a:fillRect/>
+          </a:stretch>
+        </p:blipFill>
+        <p:spPr>
+          <a:xfrm>
+            <a:off x="7686435" y="1700784"/>
+            <a:ext cx="2640810" cy="4187952"/>
+          </a:xfrm>
+          <a:prstGeom prst="rect">
+            <a:avLst/>
+          </a:prstGeom>
+        </p:spPr>
+      </p:pic>
+      <p:sp>
+        <p:nvSpPr>
+          <p:cNvPr id="13" name="TextBox 12"/>
           <p:cNvSpPr txBox="1"/>
           <p:nvPr/>
         </p:nvSpPr>
         <p:spPr>
           <a:xfrm>
-            <a:off x="6675120" y="1783080"/>
-            <a:ext cx="4663440" cy="548640"/>
+            <a:off x="6400800" y="6053328"/>
+            <a:ext cx="5212080" cy="457200"/>
           </a:xfrm>
           <a:prstGeom prst="rect">
             <a:avLst/>
@@ -11729,155 +11733,13 @@
               </a:spcAft>
             </a:pPr>
             <a:r>
-              <a:rPr sz="1800" b="1" i="0">
-                <a:solidFill>
-                  <a:srgbClr val="F2B8C6"/>
-                </a:solidFill>
-                <a:latin typeface="Calibri"/>
-              </a:rPr>
-              <a:t>Движение «шагами»</a:t>
-            </a:r>
-          </a:p>
-        </p:txBody>
-      </p:sp>
-      <p:sp>
-        <p:nvSpPr>
-          <p:cNvPr id="13" name="TextBox 12"/>
-          <p:cNvSpPr txBox="1"/>
-          <p:nvPr/>
-        </p:nvSpPr>
-        <p:spPr>
-          <a:xfrm>
-            <a:off x="6675120" y="2468880"/>
-            <a:ext cx="4663440" cy="3291840"/>
-          </a:xfrm>
-          <a:prstGeom prst="rect">
-            <a:avLst/>
-          </a:prstGeom>
-          <a:noFill/>
-        </p:spPr>
-        <p:txBody>
-          <a:bodyPr wrap="square" anchor="t">
-            <a:spAutoFit/>
-          </a:bodyPr>
-          <a:lstStyle/>
-          <a:p>
-            <a:pPr>
-              <a:spcAft>
-                <a:spcPts val="1400"/>
-              </a:spcAft>
-            </a:pPr>
-            <a:r>
-              <a:rPr sz="1500" b="1" i="0">
-                <a:solidFill>
-                  <a:srgbClr val="E8A83A"/>
-                </a:solidFill>
-                <a:latin typeface="Calibri"/>
-              </a:rPr>
-              <a:t>●  </a:t>
-            </a:r>
-            <a:r>
-              <a:rPr sz="1500" b="0" i="0">
-                <a:solidFill>
-                  <a:srgbClr val="F7E2E8"/>
-                </a:solidFill>
-                <a:latin typeface="Calibri"/>
-              </a:rPr>
-              <a:t>1. Прикрепляется задней присоской</a:t>
-            </a:r>
-          </a:p>
-          <a:p>
-            <a:pPr>
-              <a:spcAft>
-                <a:spcPts val="1400"/>
-              </a:spcAft>
-            </a:pPr>
-            <a:r>
-              <a:rPr sz="1500" b="1" i="0">
-                <a:solidFill>
-                  <a:srgbClr val="E8A83A"/>
-                </a:solidFill>
-                <a:latin typeface="Calibri"/>
-              </a:rPr>
-              <a:t>●  </a:t>
-            </a:r>
-            <a:r>
-              <a:rPr sz="1500" b="0" i="0">
-                <a:solidFill>
-                  <a:srgbClr val="F7E2E8"/>
-                </a:solidFill>
-                <a:latin typeface="Calibri"/>
-              </a:rPr>
-              <a:t>2. Вытягивает тело вперёд</a:t>
-            </a:r>
-          </a:p>
-          <a:p>
-            <a:pPr>
-              <a:spcAft>
-                <a:spcPts val="1400"/>
-              </a:spcAft>
-            </a:pPr>
-            <a:r>
-              <a:rPr sz="1500" b="1" i="0">
-                <a:solidFill>
-                  <a:srgbClr val="E8A83A"/>
-                </a:solidFill>
-                <a:latin typeface="Calibri"/>
-              </a:rPr>
-              <a:t>●  </a:t>
-            </a:r>
-            <a:r>
-              <a:rPr sz="1500" b="0" i="0">
-                <a:solidFill>
-                  <a:srgbClr val="F7E2E8"/>
-                </a:solidFill>
-                <a:latin typeface="Calibri"/>
-              </a:rPr>
-              <a:t>3. Цепляется передней присоской</a:t>
-            </a:r>
-          </a:p>
-          <a:p>
-            <a:pPr>
-              <a:spcAft>
-                <a:spcPts val="1400"/>
-              </a:spcAft>
-            </a:pPr>
-            <a:r>
-              <a:rPr sz="1500" b="1" i="0">
-                <a:solidFill>
-                  <a:srgbClr val="E8A83A"/>
-                </a:solidFill>
-                <a:latin typeface="Calibri"/>
-              </a:rPr>
-              <a:t>●  </a:t>
-            </a:r>
-            <a:r>
-              <a:rPr sz="1500" b="0" i="0">
-                <a:solidFill>
-                  <a:srgbClr val="F7E2E8"/>
-                </a:solidFill>
-                <a:latin typeface="Calibri"/>
-              </a:rPr>
-              <a:t>4. Подтягивает заднюю — шаг готов</a:t>
-            </a:r>
-          </a:p>
-          <a:p>
-            <a:pPr algn="l">
-              <a:spcBef>
-                <a:spcPts val="600"/>
-              </a:spcBef>
-              <a:spcAft>
-                <a:spcPts val="0"/>
-              </a:spcAft>
-            </a:pPr>
-            <a:r>
-              <a:rPr sz="1300" b="0" i="1">
-                <a:solidFill>
-                  <a:srgbClr val="E8B0C0"/>
-                </a:solidFill>
-                <a:latin typeface="Calibri"/>
-              </a:rPr>
-              <a:t>Две присоски дают две точки опоры — одна, как у осьминога, не позволила бы так двигаться.</a:t>
+              <a:rPr sz="900" b="0" i="1">
+                <a:solidFill>
+                  <a:srgbClr val="5A6B7B"/>
+                </a:solidFill>
+                <a:latin typeface="Calibri"/>
+              </a:rPr>
+              <a:t>Схема строения пиявки: передняя и задняя присоски, поясок, половые отверстия, папиллы.</a:t>
             </a:r>
           </a:p>
         </p:txBody>

</xml_diff>